<commit_message>
docs: promote job-seeker column to MVP status on pitch deck slide 10
Slide 10's third column (Соискатели: доска вакансий, отзывы
сотрудников, портфолио, чат) was already fully laid out but marked
"Вторая волна" with hollow-circle bullets, and the intro line said
"MVP связывает две стороны... доска вакансий во вторую волну" --
stale since the marketing-research SRS update moved the job board
into MVP (FR-36/37) well before this session, and today added
employer reviews (FR-41) on top of it.

No layout changes needed -- the column already existed at the right
size/position, just flipped to match the other two: checkmarks
instead of hollow circles, "MVP · Бесплатно" badge, and the intro
paragraph now states the three-sided market plainly. Subtitle
tightened to "отзывы о работодателе" to match FR-41's actual
terminology.
</commit_message>
<xml_diff>
--- a/docs/EduHub_Presentation_Full_Pro.pptx
+++ b/docs/EduHub_Presentation_Full_Pro.pptx
@@ -3661,7 +3661,7 @@
                 <a:ea typeface="Calibri" pitchFamily="34" charset="-122"/>
                 <a:cs typeface="Calibri" pitchFamily="34" charset="-120"/>
               </a:rPr>
-              <a:t>В MVP платформа связывает две стороны. Соискатели и доска вакансий — во вторую волну.</a:t>
+              <a:t>EduHub — трёхсторонний рынок с первого дня: родители, учреждения и соискатели-педагоги.</a:t>
             </a:r>
             <a:endParaRPr lang="en-US" sz="1400" dirty="0"/>
           </a:p>
@@ -5057,7 +5057,7 @@
                 <a:ea typeface="Calibri" pitchFamily="34" charset="-122"/>
                 <a:cs typeface="Calibri" pitchFamily="34" charset="-120"/>
               </a:rPr>
-              <a:t>Вакансии, рейтинг работодателей</a:t>
+              <a:t>Вакансии, отзывы о работодателе</a:t>
             </a:r>
             <a:endParaRPr lang="en-US" sz="1050" dirty="0"/>
           </a:p>
@@ -5096,7 +5096,7 @@
                 <a:ea typeface="Calibri" pitchFamily="34" charset="-122"/>
                 <a:cs typeface="Calibri" pitchFamily="34" charset="-120"/>
               </a:rPr>
-              <a:t>○</a:t>
+              <a:t>✓</a:t>
             </a:r>
             <a:endParaRPr lang="en-US" sz="1300" dirty="0"/>
           </a:p>
@@ -5174,7 +5174,7 @@
                 <a:ea typeface="Calibri" pitchFamily="34" charset="-122"/>
                 <a:cs typeface="Calibri" pitchFamily="34" charset="-120"/>
               </a:rPr>
-              <a:t>○</a:t>
+              <a:t>✓</a:t>
             </a:r>
             <a:endParaRPr lang="en-US" sz="1300" dirty="0"/>
           </a:p>
@@ -5252,7 +5252,7 @@
                 <a:ea typeface="Calibri" pitchFamily="34" charset="-122"/>
                 <a:cs typeface="Calibri" pitchFamily="34" charset="-120"/>
               </a:rPr>
-              <a:t>○</a:t>
+              <a:t>✓</a:t>
             </a:r>
             <a:endParaRPr lang="en-US" sz="1300" dirty="0"/>
           </a:p>
@@ -5330,7 +5330,7 @@
                 <a:ea typeface="Calibri" pitchFamily="34" charset="-122"/>
                 <a:cs typeface="Calibri" pitchFamily="34" charset="-120"/>
               </a:rPr>
-              <a:t>○</a:t>
+              <a:t>✓</a:t>
             </a:r>
             <a:endParaRPr lang="en-US" sz="1300" dirty="0"/>
           </a:p>
@@ -5434,7 +5434,7 @@
                 <a:ea typeface="Calibri" pitchFamily="34" charset="-122"/>
                 <a:cs typeface="Calibri" pitchFamily="34" charset="-120"/>
               </a:rPr>
-              <a:t>Вторая волна</a:t>
+              <a:t>MVP · Бесплатно</a:t>
             </a:r>
             <a:endParaRPr lang="en-US" sz="1150" dirty="0"/>
           </a:p>

</xml_diff>

<commit_message>
docs: fix slide 21 deferred-features list -- job board is MVP now
Same drift caught on slide 10: this card still listed the vacancy
board as second-wave, contradicting its own MVP status (FR-36/37)
and the fix just made two commits ago. Swapped it for the actual
second-wave item on that side of the feature (reverse CV search by
institutions), which was never represented on this slide before.
</commit_message>
<xml_diff>
--- a/docs/EduHub_Presentation_Full_Pro.pptx
+++ b/docs/EduHub_Presentation_Full_Pro.pptx
@@ -18970,7 +18970,7 @@
                   <a:srgbClr val="1B3A5C"/>
                 </a:solidFill>
               </a:rPr>
-              <a:t>Доска вакансий</a:t>
+              <a:t>CV-база соискателей</a:t>
             </a:r>
             <a:endParaRPr lang="en-US" sz="1500" dirty="0"/>
           </a:p>
@@ -19026,7 +19026,7 @@
                 <a:ea typeface="Calibri" pitchFamily="34" charset="-122"/>
                 <a:cs typeface="Calibri" pitchFamily="34" charset="-120"/>
               </a:rPr>
-              <a:t>Фактически отдельный продукт; добавляем после запуска основного</a:t>
+              <a:t>Обратный поиск учреждениями — отдельный модуль, откладываем до роста базы соискателей</a:t>
             </a:r>
             <a:endParaRPr lang="en-US" sz="1150" dirty="0"/>
           </a:p>

</xml_diff>